<commit_message>
Actualiza portadas de presentaciones con datos de Johan
</commit_message>
<xml_diff>
--- a/content/resources/clase-10/Clase10_parte1.pptx
+++ b/content/resources/clase-10/Clase10_parte1.pptx
@@ -18523,7 +18523,7 @@
                 <a:cs typeface="Roboto"/>
                 <a:sym typeface="Roboto"/>
               </a:rPr>
-              <a:t>Reinel Tabares Soto</a:t>
+              <a:t>Johan Sebastian Piña Duran</a:t>
             </a:r>
             <a:endParaRPr i="0" sz="2000" u="none" cap="none" strike="noStrike">
               <a:solidFill>
@@ -18727,7 +18727,7 @@
                 <a:cs typeface="Roboto"/>
                 <a:sym typeface="Roboto"/>
               </a:rPr>
-              <a:t>reinel.tabares@ucaldas.edu.co</a:t>
+              <a:t>johan.duran@ucaldas.edu.co</a:t>
             </a:r>
             <a:endParaRPr i="0" sz="2000" u="none" cap="none" strike="noStrike">
               <a:solidFill>

</xml_diff>